<commit_message>
Add 'Built in two days' slide to full lab stack deck
Slide 8: physical and digital work from Oct 24-25 (489 commits, PRs #1-#31).

Co-Authored-By: Claude Opus 5.5 (1M context) <noreply@anthropic.com>
Claude-Session: https://claude.ai/code/session_01XpppmWpR4vygMzQKAj9uez
</commit_message>
<xml_diff>
--- a/docs/slides/baebugs_full_lab_stack.pptx
+++ b/docs/slides/baebugs_full_lab_stack.pptx
@@ -12,6 +12,7 @@
     <p:sldId id="266" r:id="rId12"/>
     <p:sldId id="267" r:id="rId13"/>
     <p:sldId id="269" r:id="rId20"/>
+    <p:sldId id="271" r:id="rId22"/>
     <p:sldId id="270" r:id="rId21"/>
     <p:sldId id="260" r:id="rId6"/>
     <p:sldId id="261" r:id="rId7"/>
@@ -5051,6 +5052,734 @@
         <p:txBody>
           <a:bodyPr wrap="square" lIns="0" tIns="0" rIns="0" bIns="0" rtlCol="0" anchor="t">
             <a:noAutofit/>
+          </a:bodyPr>
+          <a:lstStyle/>
+          <a:p>
+            <a:pPr algn="l" indent="0" marL="0">
+              <a:lnSpc>
+                <a:spcPts val="1680"/>
+              </a:lnSpc>
+              <a:buNone/>
+            </a:pPr>
+            <a:r>
+              <a:rPr lang="en-US" sz="1200" dirty="0">
+                <a:solidFill>
+                  <a:srgbClr val="6B7370"/>
+                </a:solidFill>
+                <a:latin typeface="Arial" pitchFamily="34" charset="0"/>
+                <a:ea typeface="Arial" pitchFamily="34" charset="-122"/>
+                <a:cs typeface="Arial" pitchFamily="34" charset="-120"/>
+              </a:rPr>
+              <a:t>BaeBugs · BioKEA Track A</a:t>
+            </a:r>
+            <a:endParaRPr lang="en-US" sz="1200" dirty="0"/>
+          </a:p>
+        </p:txBody>
+      </p:sp>
+    </p:spTree>
+  </p:cSld>
+  <p:clrMapOvr>
+    <a:masterClrMapping/>
+  </p:clrMapOvr>
+</p:sld>
+</file>
+
+<file path=ppt/slides/slide16.xml><?xml version="1.0" encoding="utf-8"?>
+<p:sld xmlns:a="http://schemas.openxmlformats.org/drawingml/2006/main" xmlns:p="http://schemas.openxmlformats.org/presentationml/2006/main" xmlns:r="http://schemas.openxmlformats.org/officeDocument/2006/relationships">
+  <p:cSld>
+    <p:spTree>
+      <p:nvGrpSpPr>
+        <p:cNvPr id="1" name=""/>
+        <p:cNvGrpSpPr/>
+        <p:nvPr/>
+      </p:nvGrpSpPr>
+      <p:grpSpPr/>
+      <p:sp>
+        <p:nvSpPr>
+          <p:cNvPr id="2" name="Text 0"/>
+          <p:cNvSpPr/>
+          <p:nvPr/>
+        </p:nvSpPr>
+        <p:spPr>
+          <a:xfrm>
+            <a:off x="812800" y="812800"/>
+            <a:ext cx="10883392" cy="274320"/>
+          </a:xfrm>
+          <a:prstGeom prst="rect">
+            <a:avLst/>
+          </a:prstGeom>
+          <a:noFill/>
+          <a:ln/>
+        </p:spPr>
+        <p:txBody>
+          <a:bodyPr wrap="square" lIns="0" tIns="0" rIns="0" bIns="0" rtlCol="0" anchor="t">
+            <a:noAutofit/>
+          </a:bodyPr>
+          <a:lstStyle/>
+          <a:p>
+            <a:pPr algn="l" indent="0" marL="0">
+              <a:lnSpc>
+                <a:spcPts val="1960"/>
+              </a:lnSpc>
+              <a:buNone/>
+            </a:pPr>
+            <a:r>
+              <a:rPr lang="en-US" sz="1400" b="1" dirty="0">
+                <a:solidFill>
+                  <a:srgbClr val="0F6E56"/>
+                </a:solidFill>
+                <a:latin typeface="Arial" pitchFamily="34" charset="0"/>
+                <a:ea typeface="Arial" pitchFamily="34" charset="-122"/>
+                <a:cs typeface="Arial" pitchFamily="34" charset="-120"/>
+              </a:rPr>
+              <a:t>Oct 24 to 25 · 489 commits · 31 PRs</a:t>
+            </a:r>
+            <a:endParaRPr lang="en-US" sz="1400" dirty="0"/>
+          </a:p>
+        </p:txBody>
+      </p:sp>
+      <p:sp>
+        <p:nvSpPr>
+          <p:cNvPr id="3" name="Text 1"/>
+          <p:cNvSpPr/>
+          <p:nvPr>
+            <p:ph type="title"/>
+          </p:nvPr>
+        </p:nvSpPr>
+        <p:spPr>
+          <a:xfrm>
+            <a:off x="812800" y="1290321"/>
+            <a:ext cx="10883392" cy="528320"/>
+          </a:xfrm>
+          <a:prstGeom prst="rect">
+            <a:avLst/>
+          </a:prstGeom>
+          <a:noFill/>
+          <a:ln/>
+        </p:spPr>
+        <p:txBody>
+          <a:bodyPr wrap="square" lIns="0" tIns="0" rIns="0" bIns="0" rtlCol="0" anchor="t">
+            <a:noAutofit/>
+          </a:bodyPr>
+          <a:lstStyle/>
+          <a:p>
+            <a:pPr algn="l" indent="0" marL="0">
+              <a:lnSpc>
+                <a:spcPts val="3960"/>
+              </a:lnSpc>
+              <a:buNone/>
+            </a:pPr>
+            <a:r>
+              <a:rPr lang="en-US" sz="3600" b="0" i="0" dirty="0">
+                <a:solidFill>
+                  <a:srgbClr val="14201F"/>
+                </a:solidFill>
+                <a:latin typeface="Arial" pitchFamily="34" charset="0"/>
+                <a:ea typeface="Arial" pitchFamily="34" charset="-122"/>
+                <a:cs typeface="Arial" pitchFamily="34" charset="-120"/>
+              </a:rPr>
+              <a:t>Built in two days: the full stack</a:t>
+            </a:r>
+            <a:endParaRPr lang="en-US" sz="3600" dirty="0"/>
+          </a:p>
+        </p:txBody>
+      </p:sp>
+      <p:sp>
+        <p:nvSpPr>
+          <p:cNvPr id="4" name="Shape 2"/>
+          <p:cNvSpPr/>
+          <p:nvPr/>
+        </p:nvSpPr>
+        <p:spPr>
+          <a:xfrm>
+            <a:off x="812800" y="2021842"/>
+            <a:ext cx="5207000" cy="2576460"/>
+          </a:xfrm>
+          <a:prstGeom prst="roundRect">
+            <a:avLst>
+              <a:gd name="adj" fmla="val 3534"/>
+            </a:avLst>
+          </a:prstGeom>
+          <a:solidFill>
+            <a:srgbClr val="FFFFFF"/>
+          </a:solidFill>
+          <a:ln/>
+        </p:spPr>
+      </p:sp>
+      <p:sp>
+        <p:nvSpPr>
+          <p:cNvPr id="5" name="Shape 3"/>
+          <p:cNvSpPr/>
+          <p:nvPr/>
+        </p:nvSpPr>
+        <p:spPr>
+          <a:xfrm>
+            <a:off x="812800" y="2021842"/>
+            <a:ext cx="5207000" cy="2156460"/>
+          </a:xfrm>
+          <a:custGeom>
+            <a:avLst/>
+            <a:gdLst/>
+            <a:ahLst/>
+            <a:cxnLst/>
+            <a:rect l="l" t="t" r="r" b="b"/>
+            <a:pathLst>
+              <a:path w="5207000" h="2156460">
+                <a:moveTo>
+                  <a:pt x="0" y="76200"/>
+                </a:moveTo>
+                <a:lnTo>
+                  <a:pt x="0" y="76200"/>
+                </a:lnTo>
+                <a:arcTo hR="76200" wR="76200" stAng="10800000" swAng="5400000"/>
+                <a:lnTo>
+                  <a:pt x="5130800" y="0"/>
+                </a:lnTo>
+                <a:arcTo hR="76200" wR="76200" stAng="16200000" swAng="5400000"/>
+                <a:lnTo>
+                  <a:pt x="5207000" y="76200"/>
+                </a:lnTo>
+                <a:arcTo hR="25400" wR="76200" stAng="0" swAng="-5400000"/>
+                <a:lnTo>
+                  <a:pt x="76200" y="50800"/>
+                </a:lnTo>
+                <a:arcTo hR="25400" wR="76200" stAng="16200000" swAng="-5400000"/>
+                <a:close/>
+              </a:path>
+            </a:pathLst>
+          </a:custGeom>
+          <a:solidFill>
+            <a:srgbClr val="0F6E56"/>
+          </a:solidFill>
+          <a:ln/>
+        </p:spPr>
+      </p:sp>
+      <p:sp>
+        <p:nvSpPr>
+          <p:cNvPr id="6" name="Text 4"/>
+          <p:cNvSpPr/>
+          <p:nvPr/>
+        </p:nvSpPr>
+        <p:spPr>
+          <a:xfrm>
+            <a:off x="1016000" y="2275842"/>
+            <a:ext cx="4944618" cy="327660"/>
+          </a:xfrm>
+          <a:prstGeom prst="rect">
+            <a:avLst/>
+          </a:prstGeom>
+          <a:noFill/>
+          <a:ln/>
+        </p:spPr>
+        <p:txBody>
+          <a:bodyPr wrap="square" lIns="0" tIns="0" rIns="0" bIns="0" rtlCol="0" anchor="t">
+            <a:normAutofit/>
+          </a:bodyPr>
+          <a:lstStyle/>
+          <a:p>
+            <a:pPr algn="l" indent="0" marL="0">
+              <a:lnSpc>
+                <a:spcPts val="2380"/>
+              </a:lnSpc>
+              <a:buNone/>
+            </a:pPr>
+            <a:r>
+              <a:rPr lang="en-US" sz="1700" b="1" dirty="0">
+                <a:solidFill>
+                  <a:srgbClr val="0F6E56"/>
+                </a:solidFill>
+                <a:latin typeface="Arial" pitchFamily="34" charset="0"/>
+                <a:ea typeface="Arial" pitchFamily="34" charset="-122"/>
+                <a:cs typeface="Arial" pitchFamily="34" charset="-120"/>
+              </a:rPr>
+              <a:t>Physical</a:t>
+            </a:r>
+            <a:endParaRPr lang="en-US" sz="1700" dirty="0"/>
+          </a:p>
+        </p:txBody>
+      </p:sp>
+      <p:sp>
+        <p:nvSpPr>
+          <p:cNvPr id="7" name="Text 5"/>
+          <p:cNvSpPr/>
+          <p:nvPr/>
+        </p:nvSpPr>
+        <p:spPr>
+          <a:xfrm>
+            <a:off x="1092708" y="2654300"/>
+            <a:ext cx="4860290" cy="1766200"/>
+          </a:xfrm>
+          <a:prstGeom prst="rect">
+            <a:avLst/>
+          </a:prstGeom>
+          <a:noFill/>
+          <a:ln/>
+        </p:spPr>
+        <p:txBody>
+          <a:bodyPr wrap="square" lIns="0" tIns="0" rIns="0" bIns="0" rtlCol="0" anchor="t">
+            <a:noAutofit/>
+          </a:bodyPr>
+          <a:lstStyle/>
+          <a:p>
+            <a:pPr algn="l" marL="177292" indent="-177292">
+              <a:lnSpc>
+                <a:spcPts val="2080"/>
+              </a:lnSpc>
+              <a:buSzPct val="100000"/>
+              <a:buChar char="•"/>
+            </a:pPr>
+            <a:r>
+              <a:rPr lang="en-US" sz="1200" dirty="0">
+                <a:solidFill>
+                  <a:srgbClr val="14201F"/>
+                </a:solidFill>
+                <a:latin typeface="Arial" pitchFamily="34" charset="0"/>
+                <a:ea typeface="Arial" pitchFamily="34" charset="-122"/>
+                <a:cs typeface="Arial" pitchFamily="34" charset="-120"/>
+              </a:rPr>
+              <a:t>91 printed bug toys to train and test models</a:t>
+            </a:r>
+            <a:endParaRPr lang="en-US" sz="1600" dirty="0"/>
+          </a:p>
+          <a:p>
+            <a:pPr algn="l" marL="177292" indent="-177292">
+              <a:lnSpc>
+                <a:spcPts val="2080"/>
+              </a:lnSpc>
+              <a:buSzPct val="100000"/>
+              <a:buChar char="•"/>
+            </a:pPr>
+            <a:r>
+              <a:rPr lang="en-US" sz="1200" dirty="0">
+                <a:solidFill>
+                  <a:srgbClr val="14201F"/>
+                </a:solidFill>
+                <a:latin typeface="Arial" pitchFamily="34" charset="0"/>
+                <a:ea typeface="Arial" pitchFamily="34" charset="-122"/>
+                <a:cs typeface="Arial" pitchFamily="34" charset="-120"/>
+              </a:rPr>
+              <a:t>Models also tested on toys and food</a:t>
+            </a:r>
+            <a:endParaRPr lang="en-US" sz="1600" dirty="0"/>
+          </a:p>
+          <a:p>
+            <a:pPr algn="l" marL="177292" indent="-177292">
+              <a:lnSpc>
+                <a:spcPts val="2080"/>
+              </a:lnSpc>
+              <a:buSzPct val="100000"/>
+              <a:buChar char="•"/>
+            </a:pPr>
+            <a:r>
+              <a:rPr lang="en-US" sz="1200" dirty="0">
+                <a:solidFill>
+                  <a:srgbClr val="14201F"/>
+                </a:solidFill>
+                <a:latin typeface="Arial" pitchFamily="34" charset="0"/>
+                <a:ea typeface="Arial" pitchFamily="34" charset="-122"/>
+                <a:cs typeface="Arial" pitchFamily="34" charset="-120"/>
+              </a:rPr>
+              <a:t>Wood tower built by Wei, who also ran the printer</a:t>
+            </a:r>
+            <a:endParaRPr lang="en-US" sz="1600" dirty="0"/>
+          </a:p>
+          <a:p>
+            <a:pPr algn="l" marL="177292" indent="-177292">
+              <a:lnSpc>
+                <a:spcPts val="2080"/>
+              </a:lnSpc>
+              <a:buSzPct val="100000"/>
+              <a:buChar char="•"/>
+            </a:pPr>
+            <a:r>
+              <a:rPr lang="en-US" sz="1200" dirty="0">
+                <a:solidFill>
+                  <a:srgbClr val="14201F"/>
+                </a:solidFill>
+                <a:latin typeface="Arial" pitchFamily="34" charset="0"/>
+                <a:ea typeface="Arial" pitchFamily="34" charset="-122"/>
+                <a:cs typeface="Arial" pitchFamily="34" charset="-120"/>
+              </a:rPr>
+              <a:t>Repurposed metal cut to fit robot trays</a:t>
+            </a:r>
+            <a:endParaRPr lang="en-US" sz="1600" dirty="0"/>
+          </a:p>
+          <a:p>
+            <a:pPr algn="l" marL="177292" indent="-177292">
+              <a:lnSpc>
+                <a:spcPts val="2080"/>
+              </a:lnSpc>
+              <a:buSzPct val="100000"/>
+              <a:buChar char="•"/>
+            </a:pPr>
+            <a:r>
+              <a:rPr lang="en-US" sz="1200" dirty="0">
+                <a:solidFill>
+                  <a:srgbClr val="14201F"/>
+                </a:solidFill>
+                <a:latin typeface="Arial" pitchFamily="34" charset="0"/>
+                <a:ea typeface="Arial" pitchFamily="34" charset="-122"/>
+                <a:cs typeface="Arial" pitchFamily="34" charset="-120"/>
+              </a:rPr>
+              <a:t>SO-101 robot arm tested (PR #24)</a:t>
+            </a:r>
+            <a:endParaRPr lang="en-US" sz="1600" dirty="0"/>
+          </a:p>
+          <a:p>
+            <a:pPr algn="l" marL="177292" indent="-177292">
+              <a:lnSpc>
+                <a:spcPts val="2080"/>
+              </a:lnSpc>
+              <a:buSzPct val="100000"/>
+              <a:buChar char="•"/>
+            </a:pPr>
+            <a:r>
+              <a:rPr lang="en-US" sz="1200" dirty="0">
+                <a:solidFill>
+                  <a:srgbClr val="14201F"/>
+                </a:solidFill>
+                <a:latin typeface="Arial" pitchFamily="34" charset="0"/>
+                <a:ea typeface="Arial" pitchFamily="34" charset="-122"/>
+                <a:cs typeface="Arial" pitchFamily="34" charset="-120"/>
+              </a:rPr>
+              <a:t>Two camera lanes: Andrew and Byron</a:t>
+            </a:r>
+            <a:endParaRPr lang="en-US" sz="1600" dirty="0"/>
+          </a:p>
+        </p:txBody>
+      </p:sp>
+      <p:sp>
+        <p:nvSpPr>
+          <p:cNvPr id="8" name="Shape 6"/>
+          <p:cNvSpPr/>
+          <p:nvPr/>
+        </p:nvSpPr>
+        <p:spPr>
+          <a:xfrm>
+            <a:off x="6172200" y="2021842"/>
+            <a:ext cx="5207000" cy="2576460"/>
+          </a:xfrm>
+          <a:prstGeom prst="roundRect">
+            <a:avLst>
+              <a:gd name="adj" fmla="val 3534"/>
+            </a:avLst>
+          </a:prstGeom>
+          <a:solidFill>
+            <a:srgbClr val="FFFFFF"/>
+          </a:solidFill>
+          <a:ln/>
+        </p:spPr>
+      </p:sp>
+      <p:sp>
+        <p:nvSpPr>
+          <p:cNvPr id="9" name="Shape 7"/>
+          <p:cNvSpPr/>
+          <p:nvPr/>
+        </p:nvSpPr>
+        <p:spPr>
+          <a:xfrm>
+            <a:off x="6172200" y="2021842"/>
+            <a:ext cx="5207000" cy="2156460"/>
+          </a:xfrm>
+          <a:custGeom>
+            <a:avLst/>
+            <a:gdLst/>
+            <a:ahLst/>
+            <a:cxnLst/>
+            <a:rect l="l" t="t" r="r" b="b"/>
+            <a:pathLst>
+              <a:path w="5207000" h="2156460">
+                <a:moveTo>
+                  <a:pt x="0" y="76200"/>
+                </a:moveTo>
+                <a:lnTo>
+                  <a:pt x="0" y="76200"/>
+                </a:lnTo>
+                <a:arcTo hR="76200" wR="76200" stAng="10800000" swAng="5400000"/>
+                <a:lnTo>
+                  <a:pt x="5130800" y="0"/>
+                </a:lnTo>
+                <a:arcTo hR="76200" wR="76200" stAng="16200000" swAng="5400000"/>
+                <a:lnTo>
+                  <a:pt x="5207000" y="76200"/>
+                </a:lnTo>
+                <a:arcTo hR="25400" wR="76200" stAng="0" swAng="-5400000"/>
+                <a:lnTo>
+                  <a:pt x="76200" y="50800"/>
+                </a:lnTo>
+                <a:arcTo hR="25400" wR="76200" stAng="16200000" swAng="-5400000"/>
+                <a:close/>
+              </a:path>
+            </a:pathLst>
+          </a:custGeom>
+          <a:solidFill>
+            <a:srgbClr val="B8481F"/>
+          </a:solidFill>
+          <a:ln/>
+        </p:spPr>
+      </p:sp>
+      <p:sp>
+        <p:nvSpPr>
+          <p:cNvPr id="10" name="Text 8"/>
+          <p:cNvSpPr/>
+          <p:nvPr/>
+        </p:nvSpPr>
+        <p:spPr>
+          <a:xfrm>
+            <a:off x="6375400" y="2275842"/>
+            <a:ext cx="4944618" cy="327660"/>
+          </a:xfrm>
+          <a:prstGeom prst="rect">
+            <a:avLst/>
+          </a:prstGeom>
+          <a:noFill/>
+          <a:ln/>
+        </p:spPr>
+        <p:txBody>
+          <a:bodyPr wrap="square" lIns="0" tIns="0" rIns="0" bIns="0" rtlCol="0" anchor="t">
+            <a:normAutofit/>
+          </a:bodyPr>
+          <a:lstStyle/>
+          <a:p>
+            <a:pPr algn="l" indent="0" marL="0">
+              <a:lnSpc>
+                <a:spcPts val="2380"/>
+              </a:lnSpc>
+              <a:buNone/>
+            </a:pPr>
+            <a:r>
+              <a:rPr lang="en-US" sz="1700" b="1" dirty="0">
+                <a:solidFill>
+                  <a:srgbClr val="B8481F"/>
+                </a:solidFill>
+                <a:latin typeface="Arial" pitchFamily="34" charset="0"/>
+                <a:ea typeface="Arial" pitchFamily="34" charset="-122"/>
+                <a:cs typeface="Arial" pitchFamily="34" charset="-120"/>
+              </a:rPr>
+              <a:t>Digital</a:t>
+            </a:r>
+            <a:endParaRPr lang="en-US" sz="1700" dirty="0"/>
+          </a:p>
+        </p:txBody>
+      </p:sp>
+      <p:sp>
+        <p:nvSpPr>
+          <p:cNvPr id="11" name="Text 9"/>
+          <p:cNvSpPr/>
+          <p:nvPr/>
+        </p:nvSpPr>
+        <p:spPr>
+          <a:xfrm>
+            <a:off x="6452108" y="2654300"/>
+            <a:ext cx="4860290" cy="1766200"/>
+          </a:xfrm>
+          <a:prstGeom prst="rect">
+            <a:avLst/>
+          </a:prstGeom>
+          <a:noFill/>
+          <a:ln/>
+        </p:spPr>
+        <p:txBody>
+          <a:bodyPr wrap="square" lIns="0" tIns="0" rIns="0" bIns="0" rtlCol="0" anchor="t">
+            <a:noAutofit/>
+          </a:bodyPr>
+          <a:lstStyle/>
+          <a:p>
+            <a:pPr algn="l" marL="177292" indent="-177292">
+              <a:lnSpc>
+                <a:spcPts val="2080"/>
+              </a:lnSpc>
+              <a:buSzPct val="100000"/>
+              <a:buChar char="•"/>
+            </a:pPr>
+            <a:r>
+              <a:rPr lang="en-US" sz="1200" dirty="0">
+                <a:solidFill>
+                  <a:srgbClr val="14201F"/>
+                </a:solidFill>
+                <a:latin typeface="Arial" pitchFamily="34" charset="0"/>
+                <a:ea typeface="Arial" pitchFamily="34" charset="-122"/>
+                <a:cs typeface="Arial" pitchFamily="34" charset="-120"/>
+              </a:rPr>
+              <a:t>MCP server, CLI, three Vercel web apps</a:t>
+            </a:r>
+            <a:endParaRPr lang="en-US" sz="1600" dirty="0"/>
+          </a:p>
+          <a:p>
+            <a:pPr algn="l" marL="177292" indent="-177292">
+              <a:lnSpc>
+                <a:spcPts val="2080"/>
+              </a:lnSpc>
+              <a:buSzPct val="100000"/>
+              <a:buChar char="•"/>
+            </a:pPr>
+            <a:r>
+              <a:rPr lang="en-US" sz="1200" dirty="0">
+                <a:solidFill>
+                  <a:srgbClr val="14201F"/>
+                </a:solidFill>
+                <a:latin typeface="Arial" pitchFamily="34" charset="0"/>
+                <a:ea typeface="Arial" pitchFamily="34" charset="-122"/>
+                <a:cs typeface="Arial" pitchFamily="34" charset="-120"/>
+              </a:rPr>
+              <a:t>Trained on an M1 Mac, 3 local preprocessors</a:t>
+            </a:r>
+            <a:endParaRPr lang="en-US" sz="1600" dirty="0"/>
+          </a:p>
+          <a:p>
+            <a:pPr algn="l" marL="177292" indent="-177292">
+              <a:lnSpc>
+                <a:spcPts val="2080"/>
+              </a:lnSpc>
+              <a:buSzPct val="100000"/>
+              <a:buChar char="•"/>
+            </a:pPr>
+            <a:r>
+              <a:rPr lang="en-US" sz="1200" dirty="0">
+                <a:solidFill>
+                  <a:srgbClr val="14201F"/>
+                </a:solidFill>
+                <a:latin typeface="Arial" pitchFamily="34" charset="0"/>
+                <a:ea typeface="Arial" pitchFamily="34" charset="-122"/>
+                <a:cs typeface="Arial" pitchFamily="34" charset="-120"/>
+              </a:rPr>
+              <a:t>Python packages, datasets, deep research</a:t>
+            </a:r>
+            <a:endParaRPr lang="en-US" sz="1600" dirty="0"/>
+          </a:p>
+          <a:p>
+            <a:pPr algn="l" marL="177292" indent="-177292">
+              <a:lnSpc>
+                <a:spcPts val="2080"/>
+              </a:lnSpc>
+              <a:buSzPct val="100000"/>
+              <a:buChar char="•"/>
+            </a:pPr>
+            <a:r>
+              <a:rPr lang="en-US" sz="1200" dirty="0">
+                <a:solidFill>
+                  <a:srgbClr val="14201F"/>
+                </a:solidFill>
+                <a:latin typeface="Arial" pitchFamily="34" charset="0"/>
+                <a:ea typeface="Arial" pitchFamily="34" charset="-122"/>
+                <a:cs typeface="Arial" pitchFamily="34" charset="-120"/>
+              </a:rPr>
+              <a:t>Custody graph: 1,175 leaves, 25 breaks</a:t>
+            </a:r>
+            <a:endParaRPr lang="en-US" sz="1600" dirty="0"/>
+          </a:p>
+          <a:p>
+            <a:pPr algn="l" marL="177292" indent="-177292">
+              <a:lnSpc>
+                <a:spcPts val="2080"/>
+              </a:lnSpc>
+              <a:buSzPct val="100000"/>
+              <a:buChar char="•"/>
+            </a:pPr>
+            <a:r>
+              <a:rPr lang="en-US" sz="1200" dirty="0">
+                <a:solidFill>
+                  <a:srgbClr val="14201F"/>
+                </a:solidFill>
+                <a:latin typeface="Arial" pitchFamily="34" charset="0"/>
+                <a:ea typeface="Arial" pitchFamily="34" charset="-122"/>
+                <a:cs typeface="Arial" pitchFamily="34" charset="-120"/>
+              </a:rPr>
+              <a:t>Protocol Board, labware twin, demo reel</a:t>
+            </a:r>
+            <a:endParaRPr lang="en-US" sz="1600" dirty="0"/>
+          </a:p>
+          <a:p>
+            <a:pPr algn="l" marL="177292" indent="-177292">
+              <a:lnSpc>
+                <a:spcPts val="2080"/>
+              </a:lnSpc>
+              <a:buSzPct val="100000"/>
+              <a:buChar char="•"/>
+            </a:pPr>
+            <a:r>
+              <a:rPr lang="en-US" sz="1200" dirty="0">
+                <a:solidFill>
+                  <a:srgbClr val="14201F"/>
+                </a:solidFill>
+                <a:latin typeface="Arial" pitchFamily="34" charset="0"/>
+                <a:ea typeface="Arial" pitchFamily="34" charset="-122"/>
+                <a:cs typeface="Arial" pitchFamily="34" charset="-120"/>
+              </a:rPr>
+              <a:t>32 filters built for future runs</a:t>
+            </a:r>
+            <a:endParaRPr lang="en-US" sz="1600" dirty="0"/>
+          </a:p>
+        </p:txBody>
+      </p:sp>
+      <p:sp>
+        <p:nvSpPr>
+          <p:cNvPr id="12" name="Text 10"/>
+          <p:cNvSpPr/>
+          <p:nvPr/>
+        </p:nvSpPr>
+        <p:spPr>
+          <a:xfrm>
+            <a:off x="812800" y="4926900"/>
+            <a:ext cx="10566400" cy="657860"/>
+          </a:xfrm>
+          <a:prstGeom prst="roundRect">
+            <a:avLst>
+              <a:gd name="adj" fmla="val 15444"/>
+            </a:avLst>
+          </a:prstGeom>
+          <a:solidFill>
+            <a:srgbClr val="14201F"/>
+          </a:solidFill>
+          <a:ln/>
+        </p:spPr>
+        <p:txBody>
+          <a:bodyPr wrap="square" lIns="224242" tIns="148042" rIns="224242" bIns="122642" rtlCol="0" anchor="t">
+            <a:noAutofit/>
+          </a:bodyPr>
+          <a:lstStyle/>
+          <a:p>
+            <a:pPr algn="l" indent="0" marL="0">
+              <a:lnSpc>
+                <a:spcPts val="2380"/>
+              </a:lnSpc>
+              <a:buNone/>
+            </a:pPr>
+            <a:r>
+              <a:rPr lang="en-US" sz="1400" dirty="0">
+                <a:solidFill>
+                  <a:srgbClr val="F6F5F0"/>
+                </a:solidFill>
+                <a:latin typeface="Arial" pitchFamily="34" charset="0"/>
+                <a:ea typeface="Arial" pitchFamily="34" charset="-122"/>
+                <a:cs typeface="Arial" pitchFamily="34" charset="-120"/>
+              </a:rPr>
+              <a:t>Repo record: 275 commits on Oct 24 and 214 on Oct 25, across PRs #1 to #31</a:t>
+            </a:r>
+            <a:endParaRPr lang="en-US" sz="1700" dirty="0"/>
+          </a:p>
+        </p:txBody>
+      </p:sp>
+      <p:sp>
+        <p:nvSpPr>
+          <p:cNvPr id="13" name="Text 11"/>
+          <p:cNvSpPr/>
+          <p:nvPr/>
+        </p:nvSpPr>
+        <p:spPr>
+          <a:xfrm>
+            <a:off x="812800" y="6238242"/>
+            <a:ext cx="3432810" cy="238760"/>
+          </a:xfrm>
+          <a:prstGeom prst="rect">
+            <a:avLst/>
+          </a:prstGeom>
+          <a:noFill/>
+          <a:ln/>
+        </p:spPr>
+        <p:txBody>
+          <a:bodyPr wrap="square" lIns="0" tIns="0" rIns="0" bIns="0" rtlCol="0" anchor="t">
+            <a:normAutofit/>
           </a:bodyPr>
           <a:lstStyle/>
           <a:p>

</xml_diff>